<commit_message>
Add the structured_only row to the ablation slide
The ablation ran four configurations; slide 16 showed three. The missing
row is the one that carries the argument most directly: structured_only
scores 0.423 against 0.422 for the full hybrid, so removing the text
branch entirely costs nothing and marginally helps. Without it the claim
that text adds no measurable value rests on inference rather than on a
number the committee can read.

Row inserted between Text only and Hybrid (full), striping corrected, and
the finding card nudged down 0.12in and trimmed to keep its margin.
Values from results/grouped_cv.json, rounded to the slide's three places.

Co-Authored-By: Claude Opus 5 <noreply@anthropic.com>
Claude-Session: https://claude.ai/code/session_0199m1J8qxwDjywT1LuLy4gW
</commit_message>
<xml_diff>
--- a/defence/2_Defense_Presentation.pptx
+++ b/defence/2_Defense_Presentation.pptx
@@ -10388,7 +10388,504 @@
         </p:nvSpPr>
         <p:spPr>
           <a:xfrm>
-            <a:off x="457200" y="2560320"/>
+            <a:off x="457200" y="3063240"/>
+            <a:ext cx="2926080" cy="502920"/>
+          </a:xfrm>
+          <a:prstGeom prst="rect">
+            <a:avLst/>
+          </a:prstGeom>
+          <a:solidFill>
+            <a:srgbClr val="FFFFFF"/>
+          </a:solidFill>
+          <a:ln w="6350">
+            <a:solidFill>
+              <a:srgbClr val="D0D5DD"/>
+            </a:solidFill>
+            <a:prstDash val="solid"/>
+          </a:ln>
+        </p:spPr>
+        <p:txBody>
+          <a:bodyPr/>
+          <a:lstStyle/>
+          <a:p>
+            <a:endParaRPr lang="en-US"/>
+          </a:p>
+        </p:txBody>
+      </p:sp>
+      <p:sp>
+        <p:nvSpPr>
+          <p:cNvPr id="33" name="Text 31"/>
+          <p:cNvSpPr/>
+          <p:nvPr/>
+        </p:nvSpPr>
+        <p:spPr>
+          <a:xfrm>
+            <a:off x="457200" y="3063240"/>
+            <a:ext cx="2926080" cy="502920"/>
+          </a:xfrm>
+          <a:prstGeom prst="rect">
+            <a:avLst/>
+          </a:prstGeom>
+          <a:noFill/>
+          <a:ln/>
+        </p:spPr>
+        <p:txBody>
+          <a:bodyPr wrap="square" lIns="0" tIns="0" rIns="0" bIns="0" rtlCol="0" anchor="ctr"/>
+          <a:lstStyle/>
+          <a:p>
+            <a:pPr marL="0" indent="0" algn="ctr">
+              <a:buNone/>
+            </a:pPr>
+            <a:r>
+              <a:rPr lang="en-US" sz="1300" b="1" dirty="0">
+                <a:solidFill>
+                  <a:srgbClr val="1A1F2E"/>
+                </a:solidFill>
+                <a:latin typeface="Calibri" pitchFamily="34" charset="0"/>
+                <a:ea typeface="Calibri" pitchFamily="34" charset="-122"/>
+                <a:cs typeface="Calibri" pitchFamily="34" charset="-120"/>
+              </a:rPr>
+              <a:t>Hybrid (full)</a:t>
+            </a:r>
+            <a:endParaRPr lang="en-US" sz="1300" dirty="0"/>
+          </a:p>
+        </p:txBody>
+      </p:sp>
+      <p:sp>
+        <p:nvSpPr>
+          <p:cNvPr id="34" name="Shape 32"/>
+          <p:cNvSpPr/>
+          <p:nvPr/>
+        </p:nvSpPr>
+        <p:spPr>
+          <a:xfrm>
+            <a:off x="3383280" y="3063240"/>
+            <a:ext cx="1280160" cy="502920"/>
+          </a:xfrm>
+          <a:prstGeom prst="rect">
+            <a:avLst/>
+          </a:prstGeom>
+          <a:solidFill>
+            <a:srgbClr val="FFFFFF"/>
+          </a:solidFill>
+          <a:ln w="6350">
+            <a:solidFill>
+              <a:srgbClr val="D0D5DD"/>
+            </a:solidFill>
+            <a:prstDash val="solid"/>
+          </a:ln>
+        </p:spPr>
+        <p:txBody>
+          <a:bodyPr/>
+          <a:lstStyle/>
+          <a:p>
+            <a:endParaRPr lang="en-US"/>
+          </a:p>
+        </p:txBody>
+      </p:sp>
+      <p:sp>
+        <p:nvSpPr>
+          <p:cNvPr id="35" name="Text 33"/>
+          <p:cNvSpPr/>
+          <p:nvPr/>
+        </p:nvSpPr>
+        <p:spPr>
+          <a:xfrm>
+            <a:off x="3383280" y="3063240"/>
+            <a:ext cx="1280160" cy="502920"/>
+          </a:xfrm>
+          <a:prstGeom prst="rect">
+            <a:avLst/>
+          </a:prstGeom>
+          <a:noFill/>
+          <a:ln/>
+        </p:spPr>
+        <p:txBody>
+          <a:bodyPr wrap="square" lIns="0" tIns="0" rIns="0" bIns="0" rtlCol="0" anchor="ctr"/>
+          <a:lstStyle/>
+          <a:p>
+            <a:pPr marL="0" indent="0" algn="ctr">
+              <a:buNone/>
+            </a:pPr>
+            <a:r>
+              <a:rPr lang="en-US" sz="1300" dirty="0">
+                <a:solidFill>
+                  <a:srgbClr val="1A1F2E"/>
+                </a:solidFill>
+                <a:latin typeface="Consolas" pitchFamily="34" charset="0"/>
+                <a:ea typeface="Consolas" pitchFamily="34" charset="-122"/>
+                <a:cs typeface="Consolas" pitchFamily="34" charset="-120"/>
+              </a:rPr>
+              <a:t>0.422</a:t>
+            </a:r>
+            <a:endParaRPr lang="en-US" sz="1300" dirty="0"/>
+          </a:p>
+        </p:txBody>
+      </p:sp>
+      <p:sp>
+        <p:nvSpPr>
+          <p:cNvPr id="36" name="Shape 34"/>
+          <p:cNvSpPr/>
+          <p:nvPr/>
+        </p:nvSpPr>
+        <p:spPr>
+          <a:xfrm>
+            <a:off x="4663440" y="3063240"/>
+            <a:ext cx="1280160" cy="502920"/>
+          </a:xfrm>
+          <a:prstGeom prst="rect">
+            <a:avLst/>
+          </a:prstGeom>
+          <a:solidFill>
+            <a:srgbClr val="FFFFFF"/>
+          </a:solidFill>
+          <a:ln w="6350">
+            <a:solidFill>
+              <a:srgbClr val="D0D5DD"/>
+            </a:solidFill>
+            <a:prstDash val="solid"/>
+          </a:ln>
+        </p:spPr>
+        <p:txBody>
+          <a:bodyPr/>
+          <a:lstStyle/>
+          <a:p>
+            <a:endParaRPr lang="en-US"/>
+          </a:p>
+        </p:txBody>
+      </p:sp>
+      <p:sp>
+        <p:nvSpPr>
+          <p:cNvPr id="37" name="Text 35"/>
+          <p:cNvSpPr/>
+          <p:nvPr/>
+        </p:nvSpPr>
+        <p:spPr>
+          <a:xfrm>
+            <a:off x="4663440" y="3063240"/>
+            <a:ext cx="1280160" cy="502920"/>
+          </a:xfrm>
+          <a:prstGeom prst="rect">
+            <a:avLst/>
+          </a:prstGeom>
+          <a:noFill/>
+          <a:ln/>
+        </p:spPr>
+        <p:txBody>
+          <a:bodyPr wrap="square" lIns="0" tIns="0" rIns="0" bIns="0" rtlCol="0" anchor="ctr"/>
+          <a:lstStyle/>
+          <a:p>
+            <a:pPr marL="0" indent="0" algn="ctr">
+              <a:buNone/>
+            </a:pPr>
+            <a:r>
+              <a:rPr lang="en-US" sz="1300" dirty="0">
+                <a:solidFill>
+                  <a:srgbClr val="1A1F2E"/>
+                </a:solidFill>
+                <a:latin typeface="Consolas" pitchFamily="34" charset="0"/>
+                <a:ea typeface="Consolas" pitchFamily="34" charset="-122"/>
+                <a:cs typeface="Consolas" pitchFamily="34" charset="-120"/>
+              </a:rPr>
+              <a:t>0.064</a:t>
+            </a:r>
+            <a:endParaRPr lang="en-US" sz="1300" dirty="0"/>
+          </a:p>
+        </p:txBody>
+      </p:sp>
+      <p:sp>
+        <p:nvSpPr>
+          <p:cNvPr id="38" name="Shape 36"/>
+          <p:cNvSpPr/>
+          <p:nvPr/>
+        </p:nvSpPr>
+        <p:spPr>
+          <a:xfrm>
+            <a:off x="5943600" y="3063240"/>
+            <a:ext cx="1280160" cy="502920"/>
+          </a:xfrm>
+          <a:prstGeom prst="rect">
+            <a:avLst/>
+          </a:prstGeom>
+          <a:solidFill>
+            <a:srgbClr val="FFFFFF"/>
+          </a:solidFill>
+          <a:ln w="6350">
+            <a:solidFill>
+              <a:srgbClr val="D0D5DD"/>
+            </a:solidFill>
+            <a:prstDash val="solid"/>
+          </a:ln>
+        </p:spPr>
+        <p:txBody>
+          <a:bodyPr/>
+          <a:lstStyle/>
+          <a:p>
+            <a:endParaRPr lang="en-US"/>
+          </a:p>
+        </p:txBody>
+      </p:sp>
+      <p:sp>
+        <p:nvSpPr>
+          <p:cNvPr id="39" name="Text 37"/>
+          <p:cNvSpPr/>
+          <p:nvPr/>
+        </p:nvSpPr>
+        <p:spPr>
+          <a:xfrm>
+            <a:off x="5943600" y="3063240"/>
+            <a:ext cx="1280160" cy="502920"/>
+          </a:xfrm>
+          <a:prstGeom prst="rect">
+            <a:avLst/>
+          </a:prstGeom>
+          <a:noFill/>
+          <a:ln/>
+        </p:spPr>
+        <p:txBody>
+          <a:bodyPr wrap="square" lIns="0" tIns="0" rIns="0" bIns="0" rtlCol="0" anchor="ctr"/>
+          <a:lstStyle/>
+          <a:p>
+            <a:pPr marL="0" indent="0" algn="ctr">
+              <a:buNone/>
+            </a:pPr>
+            <a:r>
+              <a:rPr lang="en-US" sz="1300" dirty="0">
+                <a:solidFill>
+                  <a:srgbClr val="1A1F2E"/>
+                </a:solidFill>
+                <a:latin typeface="Consolas" pitchFamily="34" charset="0"/>
+                <a:ea typeface="Consolas" pitchFamily="34" charset="-122"/>
+                <a:cs typeface="Consolas" pitchFamily="34" charset="-120"/>
+              </a:rPr>
+              <a:t>0.520</a:t>
+            </a:r>
+            <a:endParaRPr lang="en-US" sz="1300" dirty="0"/>
+          </a:p>
+        </p:txBody>
+      </p:sp>
+      <p:sp>
+        <p:nvSpPr>
+          <p:cNvPr id="40" name="Shape 38"/>
+          <p:cNvSpPr/>
+          <p:nvPr/>
+        </p:nvSpPr>
+        <p:spPr>
+          <a:xfrm>
+            <a:off x="7223760" y="3063240"/>
+            <a:ext cx="1280160" cy="502920"/>
+          </a:xfrm>
+          <a:prstGeom prst="rect">
+            <a:avLst/>
+          </a:prstGeom>
+          <a:solidFill>
+            <a:srgbClr val="FFFFFF"/>
+          </a:solidFill>
+          <a:ln w="6350">
+            <a:solidFill>
+              <a:srgbClr val="D0D5DD"/>
+            </a:solidFill>
+            <a:prstDash val="solid"/>
+          </a:ln>
+        </p:spPr>
+        <p:txBody>
+          <a:bodyPr/>
+          <a:lstStyle/>
+          <a:p>
+            <a:endParaRPr lang="en-US"/>
+          </a:p>
+        </p:txBody>
+      </p:sp>
+      <p:sp>
+        <p:nvSpPr>
+          <p:cNvPr id="41" name="Text 39"/>
+          <p:cNvSpPr/>
+          <p:nvPr/>
+        </p:nvSpPr>
+        <p:spPr>
+          <a:xfrm>
+            <a:off x="7223760" y="3063240"/>
+            <a:ext cx="1280160" cy="502920"/>
+          </a:xfrm>
+          <a:prstGeom prst="rect">
+            <a:avLst/>
+          </a:prstGeom>
+          <a:noFill/>
+          <a:ln/>
+        </p:spPr>
+        <p:txBody>
+          <a:bodyPr wrap="square" lIns="0" tIns="0" rIns="0" bIns="0" rtlCol="0" anchor="ctr"/>
+          <a:lstStyle/>
+          <a:p>
+            <a:pPr marL="0" indent="0" algn="ctr">
+              <a:buNone/>
+            </a:pPr>
+            <a:r>
+              <a:rPr lang="en-US" sz="1300" dirty="0">
+                <a:solidFill>
+                  <a:srgbClr val="1A1F2E"/>
+                </a:solidFill>
+                <a:latin typeface="Consolas" pitchFamily="34" charset="0"/>
+                <a:ea typeface="Consolas" pitchFamily="34" charset="-122"/>
+                <a:cs typeface="Consolas" pitchFamily="34" charset="-120"/>
+              </a:rPr>
+              <a:t>0.369</a:t>
+            </a:r>
+            <a:endParaRPr lang="en-US" sz="1300" dirty="0"/>
+          </a:p>
+        </p:txBody>
+      </p:sp>
+      <p:sp>
+        <p:nvSpPr>
+          <p:cNvPr id="42" name="Shape 40"/>
+          <p:cNvSpPr/>
+          <p:nvPr/>
+        </p:nvSpPr>
+        <p:spPr>
+          <a:xfrm>
+            <a:off x="8503920" y="3063240"/>
+            <a:ext cx="1280160" cy="502920"/>
+          </a:xfrm>
+          <a:prstGeom prst="rect">
+            <a:avLst/>
+          </a:prstGeom>
+          <a:solidFill>
+            <a:srgbClr val="FFFFFF"/>
+          </a:solidFill>
+          <a:ln w="6350">
+            <a:solidFill>
+              <a:srgbClr val="D0D5DD"/>
+            </a:solidFill>
+            <a:prstDash val="solid"/>
+          </a:ln>
+        </p:spPr>
+        <p:txBody>
+          <a:bodyPr/>
+          <a:lstStyle/>
+          <a:p>
+            <a:endParaRPr lang="en-US"/>
+          </a:p>
+        </p:txBody>
+      </p:sp>
+      <p:sp>
+        <p:nvSpPr>
+          <p:cNvPr id="43" name="Text 41"/>
+          <p:cNvSpPr/>
+          <p:nvPr/>
+        </p:nvSpPr>
+        <p:spPr>
+          <a:xfrm>
+            <a:off x="8503920" y="3063240"/>
+            <a:ext cx="1280160" cy="502920"/>
+          </a:xfrm>
+          <a:prstGeom prst="rect">
+            <a:avLst/>
+          </a:prstGeom>
+          <a:noFill/>
+          <a:ln/>
+        </p:spPr>
+        <p:txBody>
+          <a:bodyPr wrap="square" lIns="0" tIns="0" rIns="0" bIns="0" rtlCol="0" anchor="ctr"/>
+          <a:lstStyle/>
+          <a:p>
+            <a:pPr marL="0" indent="0" algn="ctr">
+              <a:buNone/>
+            </a:pPr>
+            <a:r>
+              <a:rPr lang="en-US" sz="1300" dirty="0">
+                <a:solidFill>
+                  <a:srgbClr val="1A1F2E"/>
+                </a:solidFill>
+                <a:latin typeface="Consolas" pitchFamily="34" charset="0"/>
+                <a:ea typeface="Consolas" pitchFamily="34" charset="-122"/>
+                <a:cs typeface="Consolas" pitchFamily="34" charset="-120"/>
+              </a:rPr>
+              <a:t>0.480</a:t>
+            </a:r>
+            <a:endParaRPr lang="en-US" sz="1300" dirty="0"/>
+          </a:p>
+        </p:txBody>
+      </p:sp>
+      <p:sp>
+        <p:nvSpPr>
+          <p:cNvPr id="44" name="Shape 42"/>
+          <p:cNvSpPr/>
+          <p:nvPr/>
+        </p:nvSpPr>
+        <p:spPr>
+          <a:xfrm>
+            <a:off x="9784080" y="3063240"/>
+            <a:ext cx="1371600" cy="502920"/>
+          </a:xfrm>
+          <a:prstGeom prst="rect">
+            <a:avLst/>
+          </a:prstGeom>
+          <a:solidFill>
+            <a:srgbClr val="FFFFFF"/>
+          </a:solidFill>
+          <a:ln w="6350">
+            <a:solidFill>
+              <a:srgbClr val="D0D5DD"/>
+            </a:solidFill>
+            <a:prstDash val="solid"/>
+          </a:ln>
+        </p:spPr>
+        <p:txBody>
+          <a:bodyPr/>
+          <a:lstStyle/>
+          <a:p>
+            <a:endParaRPr lang="en-US"/>
+          </a:p>
+        </p:txBody>
+      </p:sp>
+      <p:sp>
+        <p:nvSpPr>
+          <p:cNvPr id="45" name="Text 43"/>
+          <p:cNvSpPr/>
+          <p:nvPr/>
+        </p:nvSpPr>
+        <p:spPr>
+          <a:xfrm>
+            <a:off x="9784080" y="3063240"/>
+            <a:ext cx="1371600" cy="502920"/>
+          </a:xfrm>
+          <a:prstGeom prst="rect">
+            <a:avLst/>
+          </a:prstGeom>
+          <a:noFill/>
+          <a:ln/>
+        </p:spPr>
+        <p:txBody>
+          <a:bodyPr wrap="square" lIns="0" tIns="0" rIns="0" bIns="0" rtlCol="0" anchor="ctr"/>
+          <a:lstStyle/>
+          <a:p>
+            <a:pPr marL="0" indent="0" algn="ctr">
+              <a:buNone/>
+            </a:pPr>
+            <a:r>
+              <a:rPr lang="en-US" sz="1300" dirty="0">
+                <a:solidFill>
+                  <a:srgbClr val="1A1F2E"/>
+                </a:solidFill>
+                <a:latin typeface="Consolas" pitchFamily="34" charset="0"/>
+                <a:ea typeface="Consolas" pitchFamily="34" charset="-122"/>
+                <a:cs typeface="Consolas" pitchFamily="34" charset="-120"/>
+              </a:rPr>
+              <a:t>0.824</a:t>
+            </a:r>
+            <a:endParaRPr lang="en-US" sz="1300" dirty="0"/>
+          </a:p>
+        </p:txBody>
+      </p:sp>
+      <p:sp>
+        <p:nvSpPr>
+          <p:cNvPr id="46" name="Shape 44"/>
+          <p:cNvSpPr/>
+          <p:nvPr/>
+        </p:nvSpPr>
+        <p:spPr>
+          <a:xfrm>
+            <a:off x="457200" y="3566160"/>
             <a:ext cx="2926080" cy="502920"/>
           </a:xfrm>
           <a:prstGeom prst="rect">
@@ -10414,13 +10911,13 @@
       </p:sp>
       <p:sp>
         <p:nvSpPr>
-          <p:cNvPr id="33" name="Text 31"/>
-          <p:cNvSpPr/>
-          <p:nvPr/>
-        </p:nvSpPr>
-        <p:spPr>
-          <a:xfrm>
-            <a:off x="457200" y="2560320"/>
+          <p:cNvPr id="47" name="Text 45"/>
+          <p:cNvSpPr/>
+          <p:nvPr/>
+        </p:nvSpPr>
+        <p:spPr>
+          <a:xfrm>
+            <a:off x="457200" y="3566160"/>
             <a:ext cx="2926080" cy="502920"/>
           </a:xfrm>
           <a:prstGeom prst="rect">
@@ -10445,7 +10942,7 @@
                 <a:ea typeface="Calibri" pitchFamily="34" charset="-122"/>
                 <a:cs typeface="Calibri" pitchFamily="34" charset="-120"/>
               </a:rPr>
-              <a:t>Hybrid (full)</a:t>
+              <a:t>Categorical only</a:t>
             </a:r>
             <a:endParaRPr lang="en-US" sz="1300" dirty="0"/>
           </a:p>
@@ -10453,13 +10950,13 @@
       </p:sp>
       <p:sp>
         <p:nvSpPr>
-          <p:cNvPr id="34" name="Shape 32"/>
-          <p:cNvSpPr/>
-          <p:nvPr/>
-        </p:nvSpPr>
-        <p:spPr>
-          <a:xfrm>
-            <a:off x="3383280" y="2560320"/>
+          <p:cNvPr id="48" name="Shape 46"/>
+          <p:cNvSpPr/>
+          <p:nvPr/>
+        </p:nvSpPr>
+        <p:spPr>
+          <a:xfrm>
+            <a:off x="3383280" y="3566160"/>
             <a:ext cx="1280160" cy="502920"/>
           </a:xfrm>
           <a:prstGeom prst="rect">
@@ -10485,13 +10982,13 @@
       </p:sp>
       <p:sp>
         <p:nvSpPr>
-          <p:cNvPr id="35" name="Text 33"/>
-          <p:cNvSpPr/>
-          <p:nvPr/>
-        </p:nvSpPr>
-        <p:spPr>
-          <a:xfrm>
-            <a:off x="3383280" y="2560320"/>
+          <p:cNvPr id="49" name="Text 47"/>
+          <p:cNvSpPr/>
+          <p:nvPr/>
+        </p:nvSpPr>
+        <p:spPr>
+          <a:xfrm>
+            <a:off x="3383280" y="3566160"/>
             <a:ext cx="1280160" cy="502920"/>
           </a:xfrm>
           <a:prstGeom prst="rect">
@@ -10516,7 +11013,7 @@
                 <a:ea typeface="Consolas" pitchFamily="34" charset="-122"/>
                 <a:cs typeface="Consolas" pitchFamily="34" charset="-120"/>
               </a:rPr>
-              <a:t>0.422</a:t>
+              <a:t>0.481</a:t>
             </a:r>
             <a:endParaRPr lang="en-US" sz="1300" dirty="0"/>
           </a:p>
@@ -10524,13 +11021,13 @@
       </p:sp>
       <p:sp>
         <p:nvSpPr>
-          <p:cNvPr id="36" name="Shape 34"/>
-          <p:cNvSpPr/>
-          <p:nvPr/>
-        </p:nvSpPr>
-        <p:spPr>
-          <a:xfrm>
-            <a:off x="4663440" y="2560320"/>
+          <p:cNvPr id="50" name="Shape 48"/>
+          <p:cNvSpPr/>
+          <p:nvPr/>
+        </p:nvSpPr>
+        <p:spPr>
+          <a:xfrm>
+            <a:off x="4663440" y="3566160"/>
             <a:ext cx="1280160" cy="502920"/>
           </a:xfrm>
           <a:prstGeom prst="rect">
@@ -10556,13 +11053,13 @@
       </p:sp>
       <p:sp>
         <p:nvSpPr>
-          <p:cNvPr id="37" name="Text 35"/>
-          <p:cNvSpPr/>
-          <p:nvPr/>
-        </p:nvSpPr>
-        <p:spPr>
-          <a:xfrm>
-            <a:off x="4663440" y="2560320"/>
+          <p:cNvPr id="51" name="Text 49"/>
+          <p:cNvSpPr/>
+          <p:nvPr/>
+        </p:nvSpPr>
+        <p:spPr>
+          <a:xfrm>
+            <a:off x="4663440" y="3566160"/>
             <a:ext cx="1280160" cy="502920"/>
           </a:xfrm>
           <a:prstGeom prst="rect">
@@ -10587,7 +11084,7 @@
                 <a:ea typeface="Consolas" pitchFamily="34" charset="-122"/>
                 <a:cs typeface="Consolas" pitchFamily="34" charset="-120"/>
               </a:rPr>
-              <a:t>0.064</a:t>
+              <a:t>0.077</a:t>
             </a:r>
             <a:endParaRPr lang="en-US" sz="1300" dirty="0"/>
           </a:p>
@@ -10595,13 +11092,13 @@
       </p:sp>
       <p:sp>
         <p:nvSpPr>
-          <p:cNvPr id="38" name="Shape 36"/>
-          <p:cNvSpPr/>
-          <p:nvPr/>
-        </p:nvSpPr>
-        <p:spPr>
-          <a:xfrm>
-            <a:off x="5943600" y="2560320"/>
+          <p:cNvPr id="52" name="Shape 50"/>
+          <p:cNvSpPr/>
+          <p:nvPr/>
+        </p:nvSpPr>
+        <p:spPr>
+          <a:xfrm>
+            <a:off x="5943600" y="3566160"/>
             <a:ext cx="1280160" cy="502920"/>
           </a:xfrm>
           <a:prstGeom prst="rect">
@@ -10627,13 +11124,13 @@
       </p:sp>
       <p:sp>
         <p:nvSpPr>
-          <p:cNvPr id="39" name="Text 37"/>
-          <p:cNvSpPr/>
-          <p:nvPr/>
-        </p:nvSpPr>
-        <p:spPr>
-          <a:xfrm>
-            <a:off x="5943600" y="2560320"/>
+          <p:cNvPr id="53" name="Text 51"/>
+          <p:cNvSpPr/>
+          <p:nvPr/>
+        </p:nvSpPr>
+        <p:spPr>
+          <a:xfrm>
+            <a:off x="5943600" y="3566160"/>
             <a:ext cx="1280160" cy="502920"/>
           </a:xfrm>
           <a:prstGeom prst="rect">
@@ -10658,7 +11155,7 @@
                 <a:ea typeface="Consolas" pitchFamily="34" charset="-122"/>
                 <a:cs typeface="Consolas" pitchFamily="34" charset="-120"/>
               </a:rPr>
-              <a:t>0.520</a:t>
+              <a:t>0.591</a:t>
             </a:r>
             <a:endParaRPr lang="en-US" sz="1300" dirty="0"/>
           </a:p>
@@ -10666,13 +11163,13 @@
       </p:sp>
       <p:sp>
         <p:nvSpPr>
-          <p:cNvPr id="40" name="Shape 38"/>
-          <p:cNvSpPr/>
-          <p:nvPr/>
-        </p:nvSpPr>
-        <p:spPr>
-          <a:xfrm>
-            <a:off x="7223760" y="2560320"/>
+          <p:cNvPr id="54" name="Shape 52"/>
+          <p:cNvSpPr/>
+          <p:nvPr/>
+        </p:nvSpPr>
+        <p:spPr>
+          <a:xfrm>
+            <a:off x="7223760" y="3566160"/>
             <a:ext cx="1280160" cy="502920"/>
           </a:xfrm>
           <a:prstGeom prst="rect">
@@ -10698,13 +11195,13 @@
       </p:sp>
       <p:sp>
         <p:nvSpPr>
-          <p:cNvPr id="41" name="Text 39"/>
-          <p:cNvSpPr/>
-          <p:nvPr/>
-        </p:nvSpPr>
-        <p:spPr>
-          <a:xfrm>
-            <a:off x="7223760" y="2560320"/>
+          <p:cNvPr id="55" name="Text 53"/>
+          <p:cNvSpPr/>
+          <p:nvPr/>
+        </p:nvSpPr>
+        <p:spPr>
+          <a:xfrm>
+            <a:off x="7223760" y="3566160"/>
             <a:ext cx="1280160" cy="502920"/>
           </a:xfrm>
           <a:prstGeom prst="rect">
@@ -10729,7 +11226,7 @@
                 <a:ea typeface="Consolas" pitchFamily="34" charset="-122"/>
                 <a:cs typeface="Consolas" pitchFamily="34" charset="-120"/>
               </a:rPr>
-              <a:t>0.369</a:t>
+              <a:t>0.432</a:t>
             </a:r>
             <a:endParaRPr lang="en-US" sz="1300" dirty="0"/>
           </a:p>
@@ -10737,13 +11234,13 @@
       </p:sp>
       <p:sp>
         <p:nvSpPr>
-          <p:cNvPr id="42" name="Shape 40"/>
-          <p:cNvSpPr/>
-          <p:nvPr/>
-        </p:nvSpPr>
-        <p:spPr>
-          <a:xfrm>
-            <a:off x="8503920" y="2560320"/>
+          <p:cNvPr id="56" name="Shape 54"/>
+          <p:cNvSpPr/>
+          <p:nvPr/>
+        </p:nvSpPr>
+        <p:spPr>
+          <a:xfrm>
+            <a:off x="8503920" y="3566160"/>
             <a:ext cx="1280160" cy="502920"/>
           </a:xfrm>
           <a:prstGeom prst="rect">
@@ -10769,13 +11266,13 @@
       </p:sp>
       <p:sp>
         <p:nvSpPr>
-          <p:cNvPr id="43" name="Text 41"/>
-          <p:cNvSpPr/>
-          <p:nvPr/>
-        </p:nvSpPr>
-        <p:spPr>
-          <a:xfrm>
-            <a:off x="8503920" y="2560320"/>
+          <p:cNvPr id="57" name="Text 55"/>
+          <p:cNvSpPr/>
+          <p:nvPr/>
+        </p:nvSpPr>
+        <p:spPr>
+          <a:xfrm>
+            <a:off x="8503920" y="3566160"/>
             <a:ext cx="1280160" cy="502920"/>
           </a:xfrm>
           <a:prstGeom prst="rect">
@@ -10800,7 +11297,7 @@
                 <a:ea typeface="Consolas" pitchFamily="34" charset="-122"/>
                 <a:cs typeface="Consolas" pitchFamily="34" charset="-120"/>
               </a:rPr>
-              <a:t>0.480</a:t>
+              <a:t>0.547</a:t>
             </a:r>
             <a:endParaRPr lang="en-US" sz="1300" dirty="0"/>
           </a:p>
@@ -10808,13 +11305,13 @@
       </p:sp>
       <p:sp>
         <p:nvSpPr>
-          <p:cNvPr id="44" name="Shape 42"/>
-          <p:cNvSpPr/>
-          <p:nvPr/>
-        </p:nvSpPr>
-        <p:spPr>
-          <a:xfrm>
-            <a:off x="9784080" y="2560320"/>
+          <p:cNvPr id="58" name="Shape 56"/>
+          <p:cNvSpPr/>
+          <p:nvPr/>
+        </p:nvSpPr>
+        <p:spPr>
+          <a:xfrm>
+            <a:off x="9784080" y="3566160"/>
             <a:ext cx="1371600" cy="502920"/>
           </a:xfrm>
           <a:prstGeom prst="rect">
@@ -10840,13 +11337,13 @@
       </p:sp>
       <p:sp>
         <p:nvSpPr>
-          <p:cNvPr id="45" name="Text 43"/>
-          <p:cNvSpPr/>
-          <p:nvPr/>
-        </p:nvSpPr>
-        <p:spPr>
-          <a:xfrm>
-            <a:off x="9784080" y="2560320"/>
+          <p:cNvPr id="59" name="Text 57"/>
+          <p:cNvSpPr/>
+          <p:nvPr/>
+        </p:nvSpPr>
+        <p:spPr>
+          <a:xfrm>
+            <a:off x="9784080" y="3566160"/>
             <a:ext cx="1371600" cy="502920"/>
           </a:xfrm>
           <a:prstGeom prst="rect">
@@ -10871,7 +11368,7 @@
                 <a:ea typeface="Consolas" pitchFamily="34" charset="-122"/>
                 <a:cs typeface="Consolas" pitchFamily="34" charset="-120"/>
               </a:rPr>
-              <a:t>0.824</a:t>
+              <a:t>0.865</a:t>
             </a:r>
             <a:endParaRPr lang="en-US" sz="1300" dirty="0"/>
           </a:p>
@@ -10879,511 +11376,14 @@
       </p:sp>
       <p:sp>
         <p:nvSpPr>
-          <p:cNvPr id="46" name="Shape 44"/>
-          <p:cNvSpPr/>
-          <p:nvPr/>
-        </p:nvSpPr>
-        <p:spPr>
-          <a:xfrm>
-            <a:off x="457200" y="3063240"/>
-            <a:ext cx="2926080" cy="502920"/>
-          </a:xfrm>
-          <a:prstGeom prst="rect">
-            <a:avLst/>
-          </a:prstGeom>
-          <a:solidFill>
-            <a:srgbClr val="FFFFFF"/>
-          </a:solidFill>
-          <a:ln w="6350">
-            <a:solidFill>
-              <a:srgbClr val="D0D5DD"/>
-            </a:solidFill>
-            <a:prstDash val="solid"/>
-          </a:ln>
-        </p:spPr>
-        <p:txBody>
-          <a:bodyPr/>
-          <a:lstStyle/>
-          <a:p>
-            <a:endParaRPr lang="en-US"/>
-          </a:p>
-        </p:txBody>
-      </p:sp>
-      <p:sp>
-        <p:nvSpPr>
-          <p:cNvPr id="47" name="Text 45"/>
-          <p:cNvSpPr/>
-          <p:nvPr/>
-        </p:nvSpPr>
-        <p:spPr>
-          <a:xfrm>
-            <a:off x="457200" y="3063240"/>
-            <a:ext cx="2926080" cy="502920"/>
-          </a:xfrm>
-          <a:prstGeom prst="rect">
-            <a:avLst/>
-          </a:prstGeom>
-          <a:noFill/>
-          <a:ln/>
-        </p:spPr>
-        <p:txBody>
-          <a:bodyPr wrap="square" lIns="0" tIns="0" rIns="0" bIns="0" rtlCol="0" anchor="ctr"/>
-          <a:lstStyle/>
-          <a:p>
-            <a:pPr marL="0" indent="0" algn="ctr">
-              <a:buNone/>
-            </a:pPr>
-            <a:r>
-              <a:rPr lang="en-US" sz="1300" b="1" dirty="0">
-                <a:solidFill>
-                  <a:srgbClr val="1A1F2E"/>
-                </a:solidFill>
-                <a:latin typeface="Calibri" pitchFamily="34" charset="0"/>
-                <a:ea typeface="Calibri" pitchFamily="34" charset="-122"/>
-                <a:cs typeface="Calibri" pitchFamily="34" charset="-120"/>
-              </a:rPr>
-              <a:t>Categorical only</a:t>
-            </a:r>
-            <a:endParaRPr lang="en-US" sz="1300" dirty="0"/>
-          </a:p>
-        </p:txBody>
-      </p:sp>
-      <p:sp>
-        <p:nvSpPr>
-          <p:cNvPr id="48" name="Shape 46"/>
-          <p:cNvSpPr/>
-          <p:nvPr/>
-        </p:nvSpPr>
-        <p:spPr>
-          <a:xfrm>
-            <a:off x="3383280" y="3063240"/>
-            <a:ext cx="1280160" cy="502920"/>
-          </a:xfrm>
-          <a:prstGeom prst="rect">
-            <a:avLst/>
-          </a:prstGeom>
-          <a:solidFill>
-            <a:srgbClr val="FFFFFF"/>
-          </a:solidFill>
-          <a:ln w="6350">
-            <a:solidFill>
-              <a:srgbClr val="D0D5DD"/>
-            </a:solidFill>
-            <a:prstDash val="solid"/>
-          </a:ln>
-        </p:spPr>
-        <p:txBody>
-          <a:bodyPr/>
-          <a:lstStyle/>
-          <a:p>
-            <a:endParaRPr lang="en-US"/>
-          </a:p>
-        </p:txBody>
-      </p:sp>
-      <p:sp>
-        <p:nvSpPr>
-          <p:cNvPr id="49" name="Text 47"/>
-          <p:cNvSpPr/>
-          <p:nvPr/>
-        </p:nvSpPr>
-        <p:spPr>
-          <a:xfrm>
-            <a:off x="3383280" y="3063240"/>
-            <a:ext cx="1280160" cy="502920"/>
-          </a:xfrm>
-          <a:prstGeom prst="rect">
-            <a:avLst/>
-          </a:prstGeom>
-          <a:noFill/>
-          <a:ln/>
-        </p:spPr>
-        <p:txBody>
-          <a:bodyPr wrap="square" lIns="0" tIns="0" rIns="0" bIns="0" rtlCol="0" anchor="ctr"/>
-          <a:lstStyle/>
-          <a:p>
-            <a:pPr marL="0" indent="0" algn="ctr">
-              <a:buNone/>
-            </a:pPr>
-            <a:r>
-              <a:rPr lang="en-US" sz="1300" dirty="0">
-                <a:solidFill>
-                  <a:srgbClr val="1A1F2E"/>
-                </a:solidFill>
-                <a:latin typeface="Consolas" pitchFamily="34" charset="0"/>
-                <a:ea typeface="Consolas" pitchFamily="34" charset="-122"/>
-                <a:cs typeface="Consolas" pitchFamily="34" charset="-120"/>
-              </a:rPr>
-              <a:t>0.481</a:t>
-            </a:r>
-            <a:endParaRPr lang="en-US" sz="1300" dirty="0"/>
-          </a:p>
-        </p:txBody>
-      </p:sp>
-      <p:sp>
-        <p:nvSpPr>
-          <p:cNvPr id="50" name="Shape 48"/>
-          <p:cNvSpPr/>
-          <p:nvPr/>
-        </p:nvSpPr>
-        <p:spPr>
-          <a:xfrm>
-            <a:off x="4663440" y="3063240"/>
-            <a:ext cx="1280160" cy="502920"/>
-          </a:xfrm>
-          <a:prstGeom prst="rect">
-            <a:avLst/>
-          </a:prstGeom>
-          <a:solidFill>
-            <a:srgbClr val="FFFFFF"/>
-          </a:solidFill>
-          <a:ln w="6350">
-            <a:solidFill>
-              <a:srgbClr val="D0D5DD"/>
-            </a:solidFill>
-            <a:prstDash val="solid"/>
-          </a:ln>
-        </p:spPr>
-        <p:txBody>
-          <a:bodyPr/>
-          <a:lstStyle/>
-          <a:p>
-            <a:endParaRPr lang="en-US"/>
-          </a:p>
-        </p:txBody>
-      </p:sp>
-      <p:sp>
-        <p:nvSpPr>
-          <p:cNvPr id="51" name="Text 49"/>
-          <p:cNvSpPr/>
-          <p:nvPr/>
-        </p:nvSpPr>
-        <p:spPr>
-          <a:xfrm>
-            <a:off x="4663440" y="3063240"/>
-            <a:ext cx="1280160" cy="502920"/>
-          </a:xfrm>
-          <a:prstGeom prst="rect">
-            <a:avLst/>
-          </a:prstGeom>
-          <a:noFill/>
-          <a:ln/>
-        </p:spPr>
-        <p:txBody>
-          <a:bodyPr wrap="square" lIns="0" tIns="0" rIns="0" bIns="0" rtlCol="0" anchor="ctr"/>
-          <a:lstStyle/>
-          <a:p>
-            <a:pPr marL="0" indent="0" algn="ctr">
-              <a:buNone/>
-            </a:pPr>
-            <a:r>
-              <a:rPr lang="en-US" sz="1300" dirty="0">
-                <a:solidFill>
-                  <a:srgbClr val="1A1F2E"/>
-                </a:solidFill>
-                <a:latin typeface="Consolas" pitchFamily="34" charset="0"/>
-                <a:ea typeface="Consolas" pitchFamily="34" charset="-122"/>
-                <a:cs typeface="Consolas" pitchFamily="34" charset="-120"/>
-              </a:rPr>
-              <a:t>0.077</a:t>
-            </a:r>
-            <a:endParaRPr lang="en-US" sz="1300" dirty="0"/>
-          </a:p>
-        </p:txBody>
-      </p:sp>
-      <p:sp>
-        <p:nvSpPr>
-          <p:cNvPr id="52" name="Shape 50"/>
-          <p:cNvSpPr/>
-          <p:nvPr/>
-        </p:nvSpPr>
-        <p:spPr>
-          <a:xfrm>
-            <a:off x="5943600" y="3063240"/>
-            <a:ext cx="1280160" cy="502920"/>
-          </a:xfrm>
-          <a:prstGeom prst="rect">
-            <a:avLst/>
-          </a:prstGeom>
-          <a:solidFill>
-            <a:srgbClr val="FFFFFF"/>
-          </a:solidFill>
-          <a:ln w="6350">
-            <a:solidFill>
-              <a:srgbClr val="D0D5DD"/>
-            </a:solidFill>
-            <a:prstDash val="solid"/>
-          </a:ln>
-        </p:spPr>
-        <p:txBody>
-          <a:bodyPr/>
-          <a:lstStyle/>
-          <a:p>
-            <a:endParaRPr lang="en-US"/>
-          </a:p>
-        </p:txBody>
-      </p:sp>
-      <p:sp>
-        <p:nvSpPr>
-          <p:cNvPr id="53" name="Text 51"/>
-          <p:cNvSpPr/>
-          <p:nvPr/>
-        </p:nvSpPr>
-        <p:spPr>
-          <a:xfrm>
-            <a:off x="5943600" y="3063240"/>
-            <a:ext cx="1280160" cy="502920"/>
-          </a:xfrm>
-          <a:prstGeom prst="rect">
-            <a:avLst/>
-          </a:prstGeom>
-          <a:noFill/>
-          <a:ln/>
-        </p:spPr>
-        <p:txBody>
-          <a:bodyPr wrap="square" lIns="0" tIns="0" rIns="0" bIns="0" rtlCol="0" anchor="ctr"/>
-          <a:lstStyle/>
-          <a:p>
-            <a:pPr marL="0" indent="0" algn="ctr">
-              <a:buNone/>
-            </a:pPr>
-            <a:r>
-              <a:rPr lang="en-US" sz="1300" dirty="0">
-                <a:solidFill>
-                  <a:srgbClr val="1A1F2E"/>
-                </a:solidFill>
-                <a:latin typeface="Consolas" pitchFamily="34" charset="0"/>
-                <a:ea typeface="Consolas" pitchFamily="34" charset="-122"/>
-                <a:cs typeface="Consolas" pitchFamily="34" charset="-120"/>
-              </a:rPr>
-              <a:t>0.591</a:t>
-            </a:r>
-            <a:endParaRPr lang="en-US" sz="1300" dirty="0"/>
-          </a:p>
-        </p:txBody>
-      </p:sp>
-      <p:sp>
-        <p:nvSpPr>
-          <p:cNvPr id="54" name="Shape 52"/>
-          <p:cNvSpPr/>
-          <p:nvPr/>
-        </p:nvSpPr>
-        <p:spPr>
-          <a:xfrm>
-            <a:off x="7223760" y="3063240"/>
-            <a:ext cx="1280160" cy="502920"/>
-          </a:xfrm>
-          <a:prstGeom prst="rect">
-            <a:avLst/>
-          </a:prstGeom>
-          <a:solidFill>
-            <a:srgbClr val="FFFFFF"/>
-          </a:solidFill>
-          <a:ln w="6350">
-            <a:solidFill>
-              <a:srgbClr val="D0D5DD"/>
-            </a:solidFill>
-            <a:prstDash val="solid"/>
-          </a:ln>
-        </p:spPr>
-        <p:txBody>
-          <a:bodyPr/>
-          <a:lstStyle/>
-          <a:p>
-            <a:endParaRPr lang="en-US"/>
-          </a:p>
-        </p:txBody>
-      </p:sp>
-      <p:sp>
-        <p:nvSpPr>
-          <p:cNvPr id="55" name="Text 53"/>
-          <p:cNvSpPr/>
-          <p:nvPr/>
-        </p:nvSpPr>
-        <p:spPr>
-          <a:xfrm>
-            <a:off x="7223760" y="3063240"/>
-            <a:ext cx="1280160" cy="502920"/>
-          </a:xfrm>
-          <a:prstGeom prst="rect">
-            <a:avLst/>
-          </a:prstGeom>
-          <a:noFill/>
-          <a:ln/>
-        </p:spPr>
-        <p:txBody>
-          <a:bodyPr wrap="square" lIns="0" tIns="0" rIns="0" bIns="0" rtlCol="0" anchor="ctr"/>
-          <a:lstStyle/>
-          <a:p>
-            <a:pPr marL="0" indent="0" algn="ctr">
-              <a:buNone/>
-            </a:pPr>
-            <a:r>
-              <a:rPr lang="en-US" sz="1300" dirty="0">
-                <a:solidFill>
-                  <a:srgbClr val="1A1F2E"/>
-                </a:solidFill>
-                <a:latin typeface="Consolas" pitchFamily="34" charset="0"/>
-                <a:ea typeface="Consolas" pitchFamily="34" charset="-122"/>
-                <a:cs typeface="Consolas" pitchFamily="34" charset="-120"/>
-              </a:rPr>
-              <a:t>0.432</a:t>
-            </a:r>
-            <a:endParaRPr lang="en-US" sz="1300" dirty="0"/>
-          </a:p>
-        </p:txBody>
-      </p:sp>
-      <p:sp>
-        <p:nvSpPr>
-          <p:cNvPr id="56" name="Shape 54"/>
-          <p:cNvSpPr/>
-          <p:nvPr/>
-        </p:nvSpPr>
-        <p:spPr>
-          <a:xfrm>
-            <a:off x="8503920" y="3063240"/>
-            <a:ext cx="1280160" cy="502920"/>
-          </a:xfrm>
-          <a:prstGeom prst="rect">
-            <a:avLst/>
-          </a:prstGeom>
-          <a:solidFill>
-            <a:srgbClr val="FFFFFF"/>
-          </a:solidFill>
-          <a:ln w="6350">
-            <a:solidFill>
-              <a:srgbClr val="D0D5DD"/>
-            </a:solidFill>
-            <a:prstDash val="solid"/>
-          </a:ln>
-        </p:spPr>
-        <p:txBody>
-          <a:bodyPr/>
-          <a:lstStyle/>
-          <a:p>
-            <a:endParaRPr lang="en-US"/>
-          </a:p>
-        </p:txBody>
-      </p:sp>
-      <p:sp>
-        <p:nvSpPr>
-          <p:cNvPr id="57" name="Text 55"/>
-          <p:cNvSpPr/>
-          <p:nvPr/>
-        </p:nvSpPr>
-        <p:spPr>
-          <a:xfrm>
-            <a:off x="8503920" y="3063240"/>
-            <a:ext cx="1280160" cy="502920"/>
-          </a:xfrm>
-          <a:prstGeom prst="rect">
-            <a:avLst/>
-          </a:prstGeom>
-          <a:noFill/>
-          <a:ln/>
-        </p:spPr>
-        <p:txBody>
-          <a:bodyPr wrap="square" lIns="0" tIns="0" rIns="0" bIns="0" rtlCol="0" anchor="ctr"/>
-          <a:lstStyle/>
-          <a:p>
-            <a:pPr marL="0" indent="0" algn="ctr">
-              <a:buNone/>
-            </a:pPr>
-            <a:r>
-              <a:rPr lang="en-US" sz="1300" dirty="0">
-                <a:solidFill>
-                  <a:srgbClr val="1A1F2E"/>
-                </a:solidFill>
-                <a:latin typeface="Consolas" pitchFamily="34" charset="0"/>
-                <a:ea typeface="Consolas" pitchFamily="34" charset="-122"/>
-                <a:cs typeface="Consolas" pitchFamily="34" charset="-120"/>
-              </a:rPr>
-              <a:t>0.547</a:t>
-            </a:r>
-            <a:endParaRPr lang="en-US" sz="1300" dirty="0"/>
-          </a:p>
-        </p:txBody>
-      </p:sp>
-      <p:sp>
-        <p:nvSpPr>
-          <p:cNvPr id="58" name="Shape 56"/>
-          <p:cNvSpPr/>
-          <p:nvPr/>
-        </p:nvSpPr>
-        <p:spPr>
-          <a:xfrm>
-            <a:off x="9784080" y="3063240"/>
-            <a:ext cx="1371600" cy="502920"/>
-          </a:xfrm>
-          <a:prstGeom prst="rect">
-            <a:avLst/>
-          </a:prstGeom>
-          <a:solidFill>
-            <a:srgbClr val="FFFFFF"/>
-          </a:solidFill>
-          <a:ln w="6350">
-            <a:solidFill>
-              <a:srgbClr val="D0D5DD"/>
-            </a:solidFill>
-            <a:prstDash val="solid"/>
-          </a:ln>
-        </p:spPr>
-        <p:txBody>
-          <a:bodyPr/>
-          <a:lstStyle/>
-          <a:p>
-            <a:endParaRPr lang="en-US"/>
-          </a:p>
-        </p:txBody>
-      </p:sp>
-      <p:sp>
-        <p:nvSpPr>
-          <p:cNvPr id="59" name="Text 57"/>
-          <p:cNvSpPr/>
-          <p:nvPr/>
-        </p:nvSpPr>
-        <p:spPr>
-          <a:xfrm>
-            <a:off x="9784080" y="3063240"/>
-            <a:ext cx="1371600" cy="502920"/>
-          </a:xfrm>
-          <a:prstGeom prst="rect">
-            <a:avLst/>
-          </a:prstGeom>
-          <a:noFill/>
-          <a:ln/>
-        </p:spPr>
-        <p:txBody>
-          <a:bodyPr wrap="square" lIns="0" tIns="0" rIns="0" bIns="0" rtlCol="0" anchor="ctr"/>
-          <a:lstStyle/>
-          <a:p>
-            <a:pPr marL="0" indent="0" algn="ctr">
-              <a:buNone/>
-            </a:pPr>
-            <a:r>
-              <a:rPr lang="en-US" sz="1300" dirty="0">
-                <a:solidFill>
-                  <a:srgbClr val="1A1F2E"/>
-                </a:solidFill>
-                <a:latin typeface="Consolas" pitchFamily="34" charset="0"/>
-                <a:ea typeface="Consolas" pitchFamily="34" charset="-122"/>
-                <a:cs typeface="Consolas" pitchFamily="34" charset="-120"/>
-              </a:rPr>
-              <a:t>0.865</a:t>
-            </a:r>
-            <a:endParaRPr lang="en-US" sz="1300" dirty="0"/>
-          </a:p>
-        </p:txBody>
-      </p:sp>
-      <p:sp>
-        <p:nvSpPr>
           <p:cNvPr id="60" name="Shape 58"/>
           <p:cNvSpPr/>
           <p:nvPr/>
         </p:nvSpPr>
         <p:spPr>
           <a:xfrm>
-            <a:off x="457200" y="4114800"/>
-            <a:ext cx="11247120" cy="2286000"/>
+            <a:off x="457200" y="4224528"/>
+            <a:ext cx="11247120" cy="2176272"/>
           </a:xfrm>
           <a:prstGeom prst="rect">
             <a:avLst/>
@@ -11414,7 +11414,7 @@
         </p:nvSpPr>
         <p:spPr>
           <a:xfrm>
-            <a:off x="640080" y="4251960"/>
+            <a:off x="640080" y="4361688"/>
             <a:ext cx="10972800" cy="411480"/>
           </a:xfrm>
           <a:prstGeom prst="rect">
@@ -11453,8 +11453,8 @@
         </p:nvSpPr>
         <p:spPr>
           <a:xfrm>
-            <a:off x="640080" y="4709160"/>
-            <a:ext cx="10972800" cy="1645920"/>
+            <a:off x="640080" y="4818888"/>
+            <a:ext cx="10972800" cy="1536192"/>
           </a:xfrm>
           <a:prstGeom prst="rect">
             <a:avLst/>
@@ -11638,6 +11638,503 @@
               <a:t>16 / 29</a:t>
             </a:r>
             <a:endParaRPr lang="en-US" sz="1000" dirty="0"/>
+          </a:p>
+        </p:txBody>
+      </p:sp>
+      <p:sp>
+        <p:nvSpPr>
+          <p:cNvPr id="18" name="Shape 16"/>
+          <p:cNvSpPr/>
+          <p:nvPr/>
+        </p:nvSpPr>
+        <p:spPr>
+          <a:xfrm>
+            <a:off x="457200" y="2560320"/>
+            <a:ext cx="2926080" cy="502920"/>
+          </a:xfrm>
+          <a:prstGeom prst="rect">
+            <a:avLst/>
+          </a:prstGeom>
+          <a:solidFill>
+            <a:srgbClr val="F7F9FB"/>
+          </a:solidFill>
+          <a:ln w="6350">
+            <a:solidFill>
+              <a:srgbClr val="D0D5DD"/>
+            </a:solidFill>
+            <a:prstDash val="solid"/>
+          </a:ln>
+        </p:spPr>
+        <p:txBody>
+          <a:bodyPr/>
+          <a:lstStyle/>
+          <a:p>
+            <a:endParaRPr lang="en-US"/>
+          </a:p>
+        </p:txBody>
+      </p:sp>
+      <p:sp>
+        <p:nvSpPr>
+          <p:cNvPr id="19" name="Text 17"/>
+          <p:cNvSpPr/>
+          <p:nvPr/>
+        </p:nvSpPr>
+        <p:spPr>
+          <a:xfrm>
+            <a:off x="457200" y="2560320"/>
+            <a:ext cx="2926080" cy="502920"/>
+          </a:xfrm>
+          <a:prstGeom prst="rect">
+            <a:avLst/>
+          </a:prstGeom>
+          <a:noFill/>
+          <a:ln/>
+        </p:spPr>
+        <p:txBody>
+          <a:bodyPr wrap="square" lIns="0" tIns="0" rIns="0" bIns="0" rtlCol="0" anchor="ctr"/>
+          <a:lstStyle/>
+          <a:p>
+            <a:pPr marL="0" indent="0" algn="ctr">
+              <a:buNone/>
+            </a:pPr>
+            <a:r>
+              <a:rPr lang="en-US" sz="1300" b="1" dirty="0">
+                <a:solidFill>
+                  <a:srgbClr val="1A1F2E"/>
+                </a:solidFill>
+                <a:latin typeface="Calibri" pitchFamily="34" charset="0"/>
+                <a:ea typeface="Calibri" pitchFamily="34" charset="-122"/>
+                <a:cs typeface="Calibri" pitchFamily="34" charset="-120"/>
+              </a:rPr>
+              <a:t>Structured only</a:t>
+            </a:r>
+            <a:endParaRPr lang="en-US" sz="1300" dirty="0"/>
+          </a:p>
+        </p:txBody>
+      </p:sp>
+      <p:sp>
+        <p:nvSpPr>
+          <p:cNvPr id="20" name="Shape 18"/>
+          <p:cNvSpPr/>
+          <p:nvPr/>
+        </p:nvSpPr>
+        <p:spPr>
+          <a:xfrm>
+            <a:off x="3383280" y="2560320"/>
+            <a:ext cx="1280160" cy="502920"/>
+          </a:xfrm>
+          <a:prstGeom prst="rect">
+            <a:avLst/>
+          </a:prstGeom>
+          <a:solidFill>
+            <a:srgbClr val="F7F9FB"/>
+          </a:solidFill>
+          <a:ln w="6350">
+            <a:solidFill>
+              <a:srgbClr val="D0D5DD"/>
+            </a:solidFill>
+            <a:prstDash val="solid"/>
+          </a:ln>
+        </p:spPr>
+        <p:txBody>
+          <a:bodyPr/>
+          <a:lstStyle/>
+          <a:p>
+            <a:endParaRPr lang="en-US"/>
+          </a:p>
+        </p:txBody>
+      </p:sp>
+      <p:sp>
+        <p:nvSpPr>
+          <p:cNvPr id="21" name="Text 19"/>
+          <p:cNvSpPr/>
+          <p:nvPr/>
+        </p:nvSpPr>
+        <p:spPr>
+          <a:xfrm>
+            <a:off x="3383280" y="2560320"/>
+            <a:ext cx="1280160" cy="502920"/>
+          </a:xfrm>
+          <a:prstGeom prst="rect">
+            <a:avLst/>
+          </a:prstGeom>
+          <a:noFill/>
+          <a:ln/>
+        </p:spPr>
+        <p:txBody>
+          <a:bodyPr wrap="square" lIns="0" tIns="0" rIns="0" bIns="0" rtlCol="0" anchor="ctr"/>
+          <a:lstStyle/>
+          <a:p>
+            <a:pPr marL="0" indent="0" algn="ctr">
+              <a:buNone/>
+            </a:pPr>
+            <a:r>
+              <a:rPr lang="en-US" sz="1300" dirty="0">
+                <a:solidFill>
+                  <a:srgbClr val="1A1F2E"/>
+                </a:solidFill>
+                <a:latin typeface="Consolas" pitchFamily="34" charset="0"/>
+                <a:ea typeface="Consolas" pitchFamily="34" charset="-122"/>
+                <a:cs typeface="Consolas" pitchFamily="34" charset="-120"/>
+              </a:rPr>
+              <a:t>0.423</a:t>
+            </a:r>
+            <a:endParaRPr lang="en-US" sz="1300" dirty="0"/>
+          </a:p>
+        </p:txBody>
+      </p:sp>
+      <p:sp>
+        <p:nvSpPr>
+          <p:cNvPr id="22" name="Shape 20"/>
+          <p:cNvSpPr/>
+          <p:nvPr/>
+        </p:nvSpPr>
+        <p:spPr>
+          <a:xfrm>
+            <a:off x="4663440" y="2560320"/>
+            <a:ext cx="1280160" cy="502920"/>
+          </a:xfrm>
+          <a:prstGeom prst="rect">
+            <a:avLst/>
+          </a:prstGeom>
+          <a:solidFill>
+            <a:srgbClr val="F7F9FB"/>
+          </a:solidFill>
+          <a:ln w="6350">
+            <a:solidFill>
+              <a:srgbClr val="D0D5DD"/>
+            </a:solidFill>
+            <a:prstDash val="solid"/>
+          </a:ln>
+        </p:spPr>
+        <p:txBody>
+          <a:bodyPr/>
+          <a:lstStyle/>
+          <a:p>
+            <a:endParaRPr lang="en-US"/>
+          </a:p>
+        </p:txBody>
+      </p:sp>
+      <p:sp>
+        <p:nvSpPr>
+          <p:cNvPr id="23" name="Text 21"/>
+          <p:cNvSpPr/>
+          <p:nvPr/>
+        </p:nvSpPr>
+        <p:spPr>
+          <a:xfrm>
+            <a:off x="4663440" y="2560320"/>
+            <a:ext cx="1280160" cy="502920"/>
+          </a:xfrm>
+          <a:prstGeom prst="rect">
+            <a:avLst/>
+          </a:prstGeom>
+          <a:noFill/>
+          <a:ln/>
+        </p:spPr>
+        <p:txBody>
+          <a:bodyPr wrap="square" lIns="0" tIns="0" rIns="0" bIns="0" rtlCol="0" anchor="ctr"/>
+          <a:lstStyle/>
+          <a:p>
+            <a:pPr marL="0" indent="0" algn="ctr">
+              <a:buNone/>
+            </a:pPr>
+            <a:r>
+              <a:rPr lang="en-US" sz="1300" dirty="0">
+                <a:solidFill>
+                  <a:srgbClr val="1A1F2E"/>
+                </a:solidFill>
+                <a:latin typeface="Consolas" pitchFamily="34" charset="0"/>
+                <a:ea typeface="Consolas" pitchFamily="34" charset="-122"/>
+                <a:cs typeface="Consolas" pitchFamily="34" charset="-120"/>
+              </a:rPr>
+              <a:t>0.066</a:t>
+            </a:r>
+            <a:endParaRPr lang="en-US" sz="1300" dirty="0"/>
+          </a:p>
+        </p:txBody>
+      </p:sp>
+      <p:sp>
+        <p:nvSpPr>
+          <p:cNvPr id="24" name="Shape 22"/>
+          <p:cNvSpPr/>
+          <p:nvPr/>
+        </p:nvSpPr>
+        <p:spPr>
+          <a:xfrm>
+            <a:off x="5943600" y="2560320"/>
+            <a:ext cx="1280160" cy="502920"/>
+          </a:xfrm>
+          <a:prstGeom prst="rect">
+            <a:avLst/>
+          </a:prstGeom>
+          <a:solidFill>
+            <a:srgbClr val="F7F9FB"/>
+          </a:solidFill>
+          <a:ln w="6350">
+            <a:solidFill>
+              <a:srgbClr val="D0D5DD"/>
+            </a:solidFill>
+            <a:prstDash val="solid"/>
+          </a:ln>
+        </p:spPr>
+        <p:txBody>
+          <a:bodyPr/>
+          <a:lstStyle/>
+          <a:p>
+            <a:endParaRPr lang="en-US"/>
+          </a:p>
+        </p:txBody>
+      </p:sp>
+      <p:sp>
+        <p:nvSpPr>
+          <p:cNvPr id="25" name="Text 23"/>
+          <p:cNvSpPr/>
+          <p:nvPr/>
+        </p:nvSpPr>
+        <p:spPr>
+          <a:xfrm>
+            <a:off x="5943600" y="2560320"/>
+            <a:ext cx="1280160" cy="502920"/>
+          </a:xfrm>
+          <a:prstGeom prst="rect">
+            <a:avLst/>
+          </a:prstGeom>
+          <a:noFill/>
+          <a:ln/>
+        </p:spPr>
+        <p:txBody>
+          <a:bodyPr wrap="square" lIns="0" tIns="0" rIns="0" bIns="0" rtlCol="0" anchor="ctr"/>
+          <a:lstStyle/>
+          <a:p>
+            <a:pPr marL="0" indent="0" algn="ctr">
+              <a:buNone/>
+            </a:pPr>
+            <a:r>
+              <a:rPr lang="en-US" sz="1300" dirty="0">
+                <a:solidFill>
+                  <a:srgbClr val="1A1F2E"/>
+                </a:solidFill>
+                <a:latin typeface="Consolas" pitchFamily="34" charset="0"/>
+                <a:ea typeface="Consolas" pitchFamily="34" charset="-122"/>
+                <a:cs typeface="Consolas" pitchFamily="34" charset="-120"/>
+              </a:rPr>
+              <a:t>0.538</a:t>
+            </a:r>
+            <a:endParaRPr lang="en-US" sz="1300" dirty="0"/>
+          </a:p>
+        </p:txBody>
+      </p:sp>
+      <p:sp>
+        <p:nvSpPr>
+          <p:cNvPr id="26" name="Shape 24"/>
+          <p:cNvSpPr/>
+          <p:nvPr/>
+        </p:nvSpPr>
+        <p:spPr>
+          <a:xfrm>
+            <a:off x="7223760" y="2560320"/>
+            <a:ext cx="1280160" cy="502920"/>
+          </a:xfrm>
+          <a:prstGeom prst="rect">
+            <a:avLst/>
+          </a:prstGeom>
+          <a:solidFill>
+            <a:srgbClr val="F7F9FB"/>
+          </a:solidFill>
+          <a:ln w="6350">
+            <a:solidFill>
+              <a:srgbClr val="D0D5DD"/>
+            </a:solidFill>
+            <a:prstDash val="solid"/>
+          </a:ln>
+        </p:spPr>
+        <p:txBody>
+          <a:bodyPr/>
+          <a:lstStyle/>
+          <a:p>
+            <a:endParaRPr lang="en-US"/>
+          </a:p>
+        </p:txBody>
+      </p:sp>
+      <p:sp>
+        <p:nvSpPr>
+          <p:cNvPr id="27" name="Text 25"/>
+          <p:cNvSpPr/>
+          <p:nvPr/>
+        </p:nvSpPr>
+        <p:spPr>
+          <a:xfrm>
+            <a:off x="7223760" y="2560320"/>
+            <a:ext cx="1280160" cy="502920"/>
+          </a:xfrm>
+          <a:prstGeom prst="rect">
+            <a:avLst/>
+          </a:prstGeom>
+          <a:noFill/>
+          <a:ln/>
+        </p:spPr>
+        <p:txBody>
+          <a:bodyPr wrap="square" lIns="0" tIns="0" rIns="0" bIns="0" rtlCol="0" anchor="ctr"/>
+          <a:lstStyle/>
+          <a:p>
+            <a:pPr marL="0" indent="0" algn="ctr">
+              <a:buNone/>
+            </a:pPr>
+            <a:r>
+              <a:rPr lang="en-US" sz="1300" dirty="0">
+                <a:solidFill>
+                  <a:srgbClr val="1A1F2E"/>
+                </a:solidFill>
+                <a:latin typeface="Consolas" pitchFamily="34" charset="0"/>
+                <a:ea typeface="Consolas" pitchFamily="34" charset="-122"/>
+                <a:cs typeface="Consolas" pitchFamily="34" charset="-120"/>
+              </a:rPr>
+              <a:t>0.361</a:t>
+            </a:r>
+            <a:endParaRPr lang="en-US" sz="1300" dirty="0"/>
+          </a:p>
+        </p:txBody>
+      </p:sp>
+      <p:sp>
+        <p:nvSpPr>
+          <p:cNvPr id="28" name="Shape 26"/>
+          <p:cNvSpPr/>
+          <p:nvPr/>
+        </p:nvSpPr>
+        <p:spPr>
+          <a:xfrm>
+            <a:off x="8503920" y="2560320"/>
+            <a:ext cx="1280160" cy="502920"/>
+          </a:xfrm>
+          <a:prstGeom prst="rect">
+            <a:avLst/>
+          </a:prstGeom>
+          <a:solidFill>
+            <a:srgbClr val="F7F9FB"/>
+          </a:solidFill>
+          <a:ln w="6350">
+            <a:solidFill>
+              <a:srgbClr val="D0D5DD"/>
+            </a:solidFill>
+            <a:prstDash val="solid"/>
+          </a:ln>
+        </p:spPr>
+        <p:txBody>
+          <a:bodyPr/>
+          <a:lstStyle/>
+          <a:p>
+            <a:endParaRPr lang="en-US"/>
+          </a:p>
+        </p:txBody>
+      </p:sp>
+      <p:sp>
+        <p:nvSpPr>
+          <p:cNvPr id="29" name="Text 27"/>
+          <p:cNvSpPr/>
+          <p:nvPr/>
+        </p:nvSpPr>
+        <p:spPr>
+          <a:xfrm>
+            <a:off x="8503920" y="2560320"/>
+            <a:ext cx="1280160" cy="502920"/>
+          </a:xfrm>
+          <a:prstGeom prst="rect">
+            <a:avLst/>
+          </a:prstGeom>
+          <a:noFill/>
+          <a:ln/>
+        </p:spPr>
+        <p:txBody>
+          <a:bodyPr wrap="square" lIns="0" tIns="0" rIns="0" bIns="0" rtlCol="0" anchor="ctr"/>
+          <a:lstStyle/>
+          <a:p>
+            <a:pPr marL="0" indent="0" algn="ctr">
+              <a:buNone/>
+            </a:pPr>
+            <a:r>
+              <a:rPr lang="en-US" sz="1300" dirty="0">
+                <a:solidFill>
+                  <a:srgbClr val="1A1F2E"/>
+                </a:solidFill>
+                <a:latin typeface="Consolas" pitchFamily="34" charset="0"/>
+                <a:ea typeface="Consolas" pitchFamily="34" charset="-122"/>
+                <a:cs typeface="Consolas" pitchFamily="34" charset="-120"/>
+              </a:rPr>
+              <a:t>0.483</a:t>
+            </a:r>
+            <a:endParaRPr lang="en-US" sz="1300" dirty="0"/>
+          </a:p>
+        </p:txBody>
+      </p:sp>
+      <p:sp>
+        <p:nvSpPr>
+          <p:cNvPr id="30" name="Shape 28"/>
+          <p:cNvSpPr/>
+          <p:nvPr/>
+        </p:nvSpPr>
+        <p:spPr>
+          <a:xfrm>
+            <a:off x="9784080" y="2560320"/>
+            <a:ext cx="1371600" cy="502920"/>
+          </a:xfrm>
+          <a:prstGeom prst="rect">
+            <a:avLst/>
+          </a:prstGeom>
+          <a:solidFill>
+            <a:srgbClr val="F7F9FB"/>
+          </a:solidFill>
+          <a:ln w="6350">
+            <a:solidFill>
+              <a:srgbClr val="D0D5DD"/>
+            </a:solidFill>
+            <a:prstDash val="solid"/>
+          </a:ln>
+        </p:spPr>
+        <p:txBody>
+          <a:bodyPr/>
+          <a:lstStyle/>
+          <a:p>
+            <a:endParaRPr lang="en-US"/>
+          </a:p>
+        </p:txBody>
+      </p:sp>
+      <p:sp>
+        <p:nvSpPr>
+          <p:cNvPr id="31" name="Text 29"/>
+          <p:cNvSpPr/>
+          <p:nvPr/>
+        </p:nvSpPr>
+        <p:spPr>
+          <a:xfrm>
+            <a:off x="9784080" y="2560320"/>
+            <a:ext cx="1371600" cy="502920"/>
+          </a:xfrm>
+          <a:prstGeom prst="rect">
+            <a:avLst/>
+          </a:prstGeom>
+          <a:noFill/>
+          <a:ln/>
+        </p:spPr>
+        <p:txBody>
+          <a:bodyPr wrap="square" lIns="0" tIns="0" rIns="0" bIns="0" rtlCol="0" anchor="ctr"/>
+          <a:lstStyle/>
+          <a:p>
+            <a:pPr marL="0" indent="0" algn="ctr">
+              <a:buNone/>
+            </a:pPr>
+            <a:r>
+              <a:rPr lang="en-US" sz="1300" dirty="0">
+                <a:solidFill>
+                  <a:srgbClr val="1A1F2E"/>
+                </a:solidFill>
+                <a:latin typeface="Consolas" pitchFamily="34" charset="0"/>
+                <a:ea typeface="Consolas" pitchFamily="34" charset="-122"/>
+                <a:cs typeface="Consolas" pitchFamily="34" charset="-120"/>
+              </a:rPr>
+              <a:t>0.820</a:t>
+            </a:r>
+            <a:endParaRPr lang="en-US" sz="1300" dirty="0"/>
           </a:p>
         </p:txBody>
       </p:sp>

</xml_diff>